<commit_message>
Corrige sequenciamento: Fase 0 classifica por sensibilidade/impacto (sem LGPD); base legal atribuida na Fase 1 (apos a aula de LGPD). Atualiza aula 01, docs/01 e dossie
</commit_message>
<xml_diff>
--- a/aulas/aula-01-contexto-e-dados.pptx
+++ b/aulas/aula-01-contexto-e-dados.pptx
@@ -3725,7 +3725,7 @@
                 </a:solidFill>
                 <a:latin typeface="Open Sans"/>
               </a:rPr>
-              <a:t>tabela Público-&gt;Crítico com base legal (LGPD).</a:t>
+              <a:t>por sensibilidade/impacto (Público -&gt; Crítico).</a:t>
             </a:r>
           </a:p>
           <a:p>
@@ -3753,7 +3753,7 @@
                 </a:solidFill>
                 <a:latin typeface="Open Sans"/>
               </a:rPr>
-              <a:t>Fluxos críticos: </a:t>
+              <a:t>Regra: </a:t>
             </a:r>
             <a:r>
               <a:rPr sz="1800">
@@ -3762,7 +3762,7 @@
                 </a:solidFill>
                 <a:latin typeface="Open Sans"/>
               </a:rPr>
-              <a:t>nomear os 3 mais sensíveis (login, laudo, auditoria).</a:t>
+              <a:t>o nível mais alto que um fluxo toca o define.</a:t>
             </a:r>
           </a:p>
           <a:p>
@@ -3790,7 +3790,7 @@
                 </a:solidFill>
                 <a:latin typeface="Open Sans"/>
               </a:rPr>
-              <a:t>Trust boundaries: </a:t>
+              <a:t>Fluxos críticos: </a:t>
             </a:r>
             <a:r>
               <a:rPr sz="1800">
@@ -3799,7 +3799,7 @@
                 </a:solidFill>
                 <a:latin typeface="Open Sans"/>
               </a:rPr>
-              <a:t>onde o dado cruza zonas de confiança.</a:t>
+              <a:t>login, laudo, auditoria.</a:t>
             </a:r>
           </a:p>
           <a:p>
@@ -3827,7 +3827,7 @@
                 </a:solidFill>
                 <a:latin typeface="Open Sans"/>
               </a:rPr>
-              <a:t>Dica: </a:t>
+              <a:t>Trust boundaries: </a:t>
             </a:r>
             <a:r>
               <a:rPr sz="1800">
@@ -3836,7 +3836,44 @@
                 </a:solidFill>
                 <a:latin typeface="Open Sans"/>
               </a:rPr>
-              <a:t>laudo de exame é dado de saúde -&gt; Crítico (LGPD art. 11).</a:t>
+              <a:t>onde o dado cruza zonas de confiança.</a:t>
+            </a:r>
+          </a:p>
+          <a:p>
+            <a:pPr algn="l">
+              <a:lnSpc>
+                <a:spcPct val="110000"/>
+              </a:lnSpc>
+              <a:spcAft>
+                <a:spcPts val="1400"/>
+              </a:spcAft>
+            </a:pPr>
+            <a:r>
+              <a:rPr sz="2000" b="1">
+                <a:solidFill>
+                  <a:srgbClr val="7CB342"/>
+                </a:solidFill>
+                <a:latin typeface="Open Sans"/>
+              </a:rPr>
+              <a:t>▸ </a:t>
+            </a:r>
+            <a:r>
+              <a:rPr sz="1800" b="1">
+                <a:solidFill>
+                  <a:srgbClr val="2D7A3D"/>
+                </a:solidFill>
+                <a:latin typeface="Open Sans"/>
+              </a:rPr>
+              <a:t>Base legal (LGPD): </a:t>
+            </a:r>
+            <a:r>
+              <a:rPr sz="1800">
+                <a:solidFill>
+                  <a:srgbClr val="212121"/>
+                </a:solidFill>
+                <a:latin typeface="Open Sans"/>
+              </a:rPr>
+              <a:t>só na Fase 1 — aqui, apenas marque o que é sensível.</a:t>
             </a:r>
           </a:p>
         </p:txBody>

</xml_diff>

<commit_message>
Slides como material de estudo: texto de tela mais explicativo, exemplos trabalhados (IDOR, BDD, STRIDE/LINDDUN-per-element) e notas de estudo (apostila embutida) em cada slide de conteudo
</commit_message>
<xml_diff>
--- a/aulas/aula-01-contexto-e-dados.pptx
+++ b/aulas/aula-01-contexto-e-dados.pptx
@@ -6,16 +6,16 @@
   </p:sldMasterIdLst>
   <p:sldIdLst>
     <p:sldId id="256" r:id="rId7"/>
-    <p:sldId id="257" r:id="rId8"/>
-    <p:sldId id="258" r:id="rId9"/>
-    <p:sldId id="259" r:id="rId10"/>
-    <p:sldId id="260" r:id="rId11"/>
-    <p:sldId id="261" r:id="rId12"/>
-    <p:sldId id="262" r:id="rId13"/>
-    <p:sldId id="263" r:id="rId14"/>
-    <p:sldId id="264" r:id="rId15"/>
-    <p:sldId id="265" r:id="rId16"/>
-    <p:sldId id="266" r:id="rId17"/>
+    <p:sldId id="257" r:id="rId9"/>
+    <p:sldId id="258" r:id="rId10"/>
+    <p:sldId id="259" r:id="rId11"/>
+    <p:sldId id="260" r:id="rId12"/>
+    <p:sldId id="261" r:id="rId13"/>
+    <p:sldId id="262" r:id="rId14"/>
+    <p:sldId id="263" r:id="rId15"/>
+    <p:sldId id="264" r:id="rId16"/>
+    <p:sldId id="265" r:id="rId17"/>
+    <p:sldId id="266" r:id="rId18"/>
   </p:sldIdLst>
   <p:sldSz cx="12191695" cy="6858000" type="screen4x3"/>
   <p:notesSz cx="6858000" cy="9144000"/>
@@ -115,6 +115,846 @@
     </a:lvl9pPr>
   </p:defaultTextStyle>
 </p:presentation>
+</file>
+
+<file path=ppt/notesMasters/notesMaster1.xml><?xml version="1.0" encoding="utf-8"?>
+<p:notesMaster xmlns:a="http://schemas.openxmlformats.org/drawingml/2006/main" xmlns:p="http://schemas.openxmlformats.org/presentationml/2006/main" xmlns:r="http://schemas.openxmlformats.org/officeDocument/2006/relationships">
+  <p:cSld>
+    <p:bg>
+      <p:bgRef idx="1001">
+        <a:schemeClr val="bg1"/>
+      </p:bgRef>
+    </p:bg>
+    <p:spTree>
+      <p:nvGrpSpPr>
+        <p:cNvPr id="1" name=""/>
+        <p:cNvGrpSpPr/>
+        <p:nvPr/>
+      </p:nvGrpSpPr>
+      <p:grpSpPr>
+        <a:xfrm>
+          <a:off x="0" y="0"/>
+          <a:ext cx="0" cy="0"/>
+          <a:chOff x="0" y="0"/>
+          <a:chExt cx="0" cy="0"/>
+        </a:xfrm>
+      </p:grpSpPr>
+      <p:sp>
+        <p:nvSpPr>
+          <p:cNvPr id="2" name="Header Placeholder 1"/>
+          <p:cNvSpPr>
+            <a:spLocks noGrp="1"/>
+          </p:cNvSpPr>
+          <p:nvPr>
+            <p:ph type="hdr" sz="quarter"/>
+          </p:nvPr>
+        </p:nvSpPr>
+        <p:spPr>
+          <a:xfrm>
+            <a:off x="0" y="0"/>
+            <a:ext cx="2971800" cy="457200"/>
+          </a:xfrm>
+          <a:prstGeom prst="rect">
+            <a:avLst/>
+          </a:prstGeom>
+        </p:spPr>
+        <p:txBody>
+          <a:bodyPr vert="horz" lIns="91440" tIns="45720" rIns="91440" bIns="45720" rtlCol="0"/>
+          <a:lstStyle>
+            <a:lvl1pPr algn="l">
+              <a:defRPr sz="1200"/>
+            </a:lvl1pPr>
+          </a:lstStyle>
+          <a:p>
+            <a:endParaRPr lang="en-US"/>
+          </a:p>
+        </p:txBody>
+      </p:sp>
+      <p:sp>
+        <p:nvSpPr>
+          <p:cNvPr id="3" name="Date Placeholder 2"/>
+          <p:cNvSpPr>
+            <a:spLocks noGrp="1"/>
+          </p:cNvSpPr>
+          <p:nvPr>
+            <p:ph type="dt" idx="1"/>
+          </p:nvPr>
+        </p:nvSpPr>
+        <p:spPr>
+          <a:xfrm>
+            <a:off x="3884613" y="0"/>
+            <a:ext cx="2971800" cy="457200"/>
+          </a:xfrm>
+          <a:prstGeom prst="rect">
+            <a:avLst/>
+          </a:prstGeom>
+        </p:spPr>
+        <p:txBody>
+          <a:bodyPr vert="horz" lIns="91440" tIns="45720" rIns="91440" bIns="45720" rtlCol="0"/>
+          <a:lstStyle>
+            <a:lvl1pPr algn="r">
+              <a:defRPr sz="1200"/>
+            </a:lvl1pPr>
+          </a:lstStyle>
+          <a:p>
+            <a:fld id="{0F89C1C7-3DCD-1040-A9CF-14679D8B5DDD}" type="datetimeFigureOut">
+              <a:rPr lang="en-US" smtClean="0"/>
+              <a:t>10/17/16</a:t>
+            </a:fld>
+            <a:endParaRPr lang="en-US"/>
+          </a:p>
+        </p:txBody>
+      </p:sp>
+      <p:sp>
+        <p:nvSpPr>
+          <p:cNvPr id="4" name="Slide Image Placeholder 3"/>
+          <p:cNvSpPr>
+            <a:spLocks noGrp="1" noRot="1" noChangeAspect="1"/>
+          </p:cNvSpPr>
+          <p:nvPr>
+            <p:ph type="sldImg" idx="2"/>
+          </p:nvPr>
+        </p:nvSpPr>
+        <p:spPr>
+          <a:xfrm>
+            <a:off x="1143000" y="685800"/>
+            <a:ext cx="4572000" cy="3429000"/>
+          </a:xfrm>
+          <a:prstGeom prst="rect">
+            <a:avLst/>
+          </a:prstGeom>
+          <a:noFill/>
+          <a:ln w="12700">
+            <a:solidFill>
+              <a:prstClr val="black"/>
+            </a:solidFill>
+          </a:ln>
+        </p:spPr>
+        <p:txBody>
+          <a:bodyPr vert="horz" lIns="91440" tIns="45720" rIns="91440" bIns="45720" rtlCol="0" anchor="ctr"/>
+          <a:lstStyle/>
+          <a:p>
+            <a:endParaRPr lang="en-US"/>
+          </a:p>
+        </p:txBody>
+      </p:sp>
+      <p:sp>
+        <p:nvSpPr>
+          <p:cNvPr id="5" name="Notes Placeholder 4"/>
+          <p:cNvSpPr>
+            <a:spLocks noGrp="1"/>
+          </p:cNvSpPr>
+          <p:nvPr>
+            <p:ph type="body" sz="quarter" idx="3"/>
+          </p:nvPr>
+        </p:nvSpPr>
+        <p:spPr>
+          <a:xfrm>
+            <a:off x="685800" y="4343400"/>
+            <a:ext cx="5486400" cy="4114800"/>
+          </a:xfrm>
+          <a:prstGeom prst="rect">
+            <a:avLst/>
+          </a:prstGeom>
+        </p:spPr>
+        <p:txBody>
+          <a:bodyPr vert="horz" lIns="91440" tIns="45720" rIns="91440" bIns="45720" rtlCol="0"/>
+          <a:lstStyle/>
+          <a:p>
+            <a:pPr lvl="0"/>
+            <a:r>
+              <a:rPr lang="en-US" smtClean="0"/>
+              <a:t>Click to edit Master text styles</a:t>
+            </a:r>
+          </a:p>
+          <a:p>
+            <a:pPr lvl="1"/>
+            <a:r>
+              <a:rPr lang="en-US" smtClean="0"/>
+              <a:t>Second level</a:t>
+            </a:r>
+          </a:p>
+          <a:p>
+            <a:pPr lvl="2"/>
+            <a:r>
+              <a:rPr lang="en-US" smtClean="0"/>
+              <a:t>Third level</a:t>
+            </a:r>
+          </a:p>
+          <a:p>
+            <a:pPr lvl="3"/>
+            <a:r>
+              <a:rPr lang="en-US" smtClean="0"/>
+              <a:t>Fourth level</a:t>
+            </a:r>
+          </a:p>
+          <a:p>
+            <a:pPr lvl="4"/>
+            <a:r>
+              <a:rPr lang="en-US" smtClean="0"/>
+              <a:t>Fifth level</a:t>
+            </a:r>
+            <a:endParaRPr lang="en-US"/>
+          </a:p>
+        </p:txBody>
+      </p:sp>
+      <p:sp>
+        <p:nvSpPr>
+          <p:cNvPr id="6" name="Footer Placeholder 5"/>
+          <p:cNvSpPr>
+            <a:spLocks noGrp="1"/>
+          </p:cNvSpPr>
+          <p:nvPr>
+            <p:ph type="ftr" sz="quarter" idx="4"/>
+          </p:nvPr>
+        </p:nvSpPr>
+        <p:spPr>
+          <a:xfrm>
+            <a:off x="0" y="8685213"/>
+            <a:ext cx="2971800" cy="457200"/>
+          </a:xfrm>
+          <a:prstGeom prst="rect">
+            <a:avLst/>
+          </a:prstGeom>
+        </p:spPr>
+        <p:txBody>
+          <a:bodyPr vert="horz" lIns="91440" tIns="45720" rIns="91440" bIns="45720" rtlCol="0" anchor="b"/>
+          <a:lstStyle>
+            <a:lvl1pPr algn="l">
+              <a:defRPr sz="1200"/>
+            </a:lvl1pPr>
+          </a:lstStyle>
+          <a:p>
+            <a:endParaRPr lang="en-US"/>
+          </a:p>
+        </p:txBody>
+      </p:sp>
+      <p:sp>
+        <p:nvSpPr>
+          <p:cNvPr id="7" name="Slide Number Placeholder 6"/>
+          <p:cNvSpPr>
+            <a:spLocks noGrp="1"/>
+          </p:cNvSpPr>
+          <p:nvPr>
+            <p:ph type="sldNum" sz="quarter" idx="5"/>
+          </p:nvPr>
+        </p:nvSpPr>
+        <p:spPr>
+          <a:xfrm>
+            <a:off x="3884613" y="8685213"/>
+            <a:ext cx="2971800" cy="457200"/>
+          </a:xfrm>
+          <a:prstGeom prst="rect">
+            <a:avLst/>
+          </a:prstGeom>
+        </p:spPr>
+        <p:txBody>
+          <a:bodyPr vert="horz" lIns="91440" tIns="45720" rIns="91440" bIns="45720" rtlCol="0" anchor="b"/>
+          <a:lstStyle>
+            <a:lvl1pPr algn="r">
+              <a:defRPr sz="1200"/>
+            </a:lvl1pPr>
+          </a:lstStyle>
+          <a:p>
+            <a:fld id="{BB5E49A5-4136-284D-997B-48E1D791AD67}" type="slidenum">
+              <a:rPr lang="en-US" smtClean="0"/>
+              <a:t>‹#›</a:t>
+            </a:fld>
+            <a:endParaRPr lang="en-US"/>
+          </a:p>
+        </p:txBody>
+      </p:sp>
+    </p:spTree>
+    <p:extLst>
+      <p:ext uri="{BB962C8B-B14F-4D97-AF65-F5344CB8AC3E}">
+        <p14:creationId xmlns:p14="http://schemas.microsoft.com/office/powerpoint/2010/main" val="2623252185"/>
+      </p:ext>
+    </p:extLst>
+  </p:cSld>
+  <p:clrMap bg1="lt1" tx1="dk1" bg2="lt2" tx2="dk2" accent1="accent1" accent2="accent2" accent3="accent3" accent4="accent4" accent5="accent5" accent6="accent6" hlink="hlink" folHlink="folHlink"/>
+  <p:notesStyle>
+    <a:lvl1pPr marL="0" algn="l" defTabSz="457200" rtl="0" eaLnBrk="1" latinLnBrk="0" hangingPunct="1">
+      <a:defRPr sz="1200" kern="1200">
+        <a:solidFill>
+          <a:schemeClr val="tx1"/>
+        </a:solidFill>
+        <a:latin typeface="+mn-lt"/>
+        <a:ea typeface="+mn-ea"/>
+        <a:cs typeface="+mn-cs"/>
+      </a:defRPr>
+    </a:lvl1pPr>
+    <a:lvl2pPr marL="457200" algn="l" defTabSz="457200" rtl="0" eaLnBrk="1" latinLnBrk="0" hangingPunct="1">
+      <a:defRPr sz="1200" kern="1200">
+        <a:solidFill>
+          <a:schemeClr val="tx1"/>
+        </a:solidFill>
+        <a:latin typeface="+mn-lt"/>
+        <a:ea typeface="+mn-ea"/>
+        <a:cs typeface="+mn-cs"/>
+      </a:defRPr>
+    </a:lvl2pPr>
+    <a:lvl3pPr marL="914400" algn="l" defTabSz="457200" rtl="0" eaLnBrk="1" latinLnBrk="0" hangingPunct="1">
+      <a:defRPr sz="1200" kern="1200">
+        <a:solidFill>
+          <a:schemeClr val="tx1"/>
+        </a:solidFill>
+        <a:latin typeface="+mn-lt"/>
+        <a:ea typeface="+mn-ea"/>
+        <a:cs typeface="+mn-cs"/>
+      </a:defRPr>
+    </a:lvl3pPr>
+    <a:lvl4pPr marL="1371600" algn="l" defTabSz="457200" rtl="0" eaLnBrk="1" latinLnBrk="0" hangingPunct="1">
+      <a:defRPr sz="1200" kern="1200">
+        <a:solidFill>
+          <a:schemeClr val="tx1"/>
+        </a:solidFill>
+        <a:latin typeface="+mn-lt"/>
+        <a:ea typeface="+mn-ea"/>
+        <a:cs typeface="+mn-cs"/>
+      </a:defRPr>
+    </a:lvl4pPr>
+    <a:lvl5pPr marL="1828800" algn="l" defTabSz="457200" rtl="0" eaLnBrk="1" latinLnBrk="0" hangingPunct="1">
+      <a:defRPr sz="1200" kern="1200">
+        <a:solidFill>
+          <a:schemeClr val="tx1"/>
+        </a:solidFill>
+        <a:latin typeface="+mn-lt"/>
+        <a:ea typeface="+mn-ea"/>
+        <a:cs typeface="+mn-cs"/>
+      </a:defRPr>
+    </a:lvl5pPr>
+    <a:lvl6pPr marL="2286000" algn="l" defTabSz="457200" rtl="0" eaLnBrk="1" latinLnBrk="0" hangingPunct="1">
+      <a:defRPr sz="1200" kern="1200">
+        <a:solidFill>
+          <a:schemeClr val="tx1"/>
+        </a:solidFill>
+        <a:latin typeface="+mn-lt"/>
+        <a:ea typeface="+mn-ea"/>
+        <a:cs typeface="+mn-cs"/>
+      </a:defRPr>
+    </a:lvl6pPr>
+    <a:lvl7pPr marL="2743200" algn="l" defTabSz="457200" rtl="0" eaLnBrk="1" latinLnBrk="0" hangingPunct="1">
+      <a:defRPr sz="1200" kern="1200">
+        <a:solidFill>
+          <a:schemeClr val="tx1"/>
+        </a:solidFill>
+        <a:latin typeface="+mn-lt"/>
+        <a:ea typeface="+mn-ea"/>
+        <a:cs typeface="+mn-cs"/>
+      </a:defRPr>
+    </a:lvl7pPr>
+    <a:lvl8pPr marL="3200400" algn="l" defTabSz="457200" rtl="0" eaLnBrk="1" latinLnBrk="0" hangingPunct="1">
+      <a:defRPr sz="1200" kern="1200">
+        <a:solidFill>
+          <a:schemeClr val="tx1"/>
+        </a:solidFill>
+        <a:latin typeface="+mn-lt"/>
+        <a:ea typeface="+mn-ea"/>
+        <a:cs typeface="+mn-cs"/>
+      </a:defRPr>
+    </a:lvl8pPr>
+    <a:lvl9pPr marL="3657600" algn="l" defTabSz="457200" rtl="0" eaLnBrk="1" latinLnBrk="0" hangingPunct="1">
+      <a:defRPr sz="1200" kern="1200">
+        <a:solidFill>
+          <a:schemeClr val="tx1"/>
+        </a:solidFill>
+        <a:latin typeface="+mn-lt"/>
+        <a:ea typeface="+mn-ea"/>
+        <a:cs typeface="+mn-cs"/>
+      </a:defRPr>
+    </a:lvl9pPr>
+  </p:notesStyle>
+</p:notesMaster>
+</file>
+
+<file path=ppt/notesSlides/notesSlide1.xml><?xml version="1.0" encoding="utf-8"?>
+<p:notes xmlns:a="http://schemas.openxmlformats.org/drawingml/2006/main" xmlns:p="http://schemas.openxmlformats.org/presentationml/2006/main" xmlns:r="http://schemas.openxmlformats.org/officeDocument/2006/relationships">
+  <p:cSld>
+    <p:spTree>
+      <p:nvGrpSpPr>
+        <p:cNvPr id="1" name=""/>
+        <p:cNvGrpSpPr/>
+        <p:nvPr/>
+      </p:nvGrpSpPr>
+      <p:grpSpPr>
+        <a:xfrm>
+          <a:off x="0" y="0"/>
+          <a:ext cx="0" cy="0"/>
+          <a:chOff x="0" y="0"/>
+          <a:chExt cx="0" cy="0"/>
+        </a:xfrm>
+      </p:grpSpPr>
+      <p:sp>
+        <p:nvSpPr>
+          <p:cNvPr id="2" name="Slide Image Placeholder 1"/>
+          <p:cNvSpPr>
+            <a:spLocks noGrp="1"/>
+          </p:cNvSpPr>
+          <p:nvPr>
+            <p:ph type="sldImg" idx="2"/>
+          </p:nvPr>
+        </p:nvSpPr>
+        <p:spPr/>
+      </p:sp>
+      <p:sp>
+        <p:nvSpPr>
+          <p:cNvPr id="3" name="Notes Placeholder 2"/>
+          <p:cNvSpPr>
+            <a:spLocks noGrp="1"/>
+          </p:cNvSpPr>
+          <p:nvPr>
+            <p:ph type="body" idx="3" sz="quarter"/>
+          </p:nvPr>
+        </p:nvSpPr>
+        <p:spPr/>
+        <p:txBody>
+          <a:bodyPr/>
+          <a:lstStyle/>
+          <a:p>
+            <a:r>
+              <a:t>Aula 1 da disciplina. Objetivo: entender por que segurança precisa estar em todo o ciclo (SSDLC) e aprender a classificar os dados de um sistema. Ao final, o grupo faz o inventário e a classificação do VidaPlus (Fase 0 do projeto).</a:t>
+            </a:r>
+          </a:p>
+        </p:txBody>
+      </p:sp>
+      <p:sp>
+        <p:nvSpPr>
+          <p:cNvPr id="4" name="Slide Number Placeholder 3"/>
+          <p:cNvSpPr>
+            <a:spLocks noGrp="1"/>
+          </p:cNvSpPr>
+          <p:nvPr>
+            <p:ph type="sldNum" idx="5" sz="quarter"/>
+          </p:nvPr>
+        </p:nvSpPr>
+        <p:spPr/>
+      </p:sp>
+    </p:spTree>
+  </p:cSld>
+  <p:clrMapOvr>
+    <a:masterClrMapping/>
+  </p:clrMapOvr>
+</p:notes>
+</file>
+
+<file path=ppt/notesSlides/notesSlide2.xml><?xml version="1.0" encoding="utf-8"?>
+<p:notes xmlns:a="http://schemas.openxmlformats.org/drawingml/2006/main" xmlns:p="http://schemas.openxmlformats.org/presentationml/2006/main" xmlns:r="http://schemas.openxmlformats.org/officeDocument/2006/relationships">
+  <p:cSld>
+    <p:spTree>
+      <p:nvGrpSpPr>
+        <p:cNvPr id="1" name=""/>
+        <p:cNvGrpSpPr/>
+        <p:nvPr/>
+      </p:nvGrpSpPr>
+      <p:grpSpPr>
+        <a:xfrm>
+          <a:off x="0" y="0"/>
+          <a:ext cx="0" cy="0"/>
+          <a:chOff x="0" y="0"/>
+          <a:chExt cx="0" cy="0"/>
+        </a:xfrm>
+      </p:grpSpPr>
+      <p:sp>
+        <p:nvSpPr>
+          <p:cNvPr id="2" name="Slide Image Placeholder 1"/>
+          <p:cNvSpPr>
+            <a:spLocks noGrp="1"/>
+          </p:cNvSpPr>
+          <p:nvPr>
+            <p:ph type="sldImg" idx="2"/>
+          </p:nvPr>
+        </p:nvSpPr>
+        <p:spPr/>
+      </p:sp>
+      <p:sp>
+        <p:nvSpPr>
+          <p:cNvPr id="3" name="Notes Placeholder 2"/>
+          <p:cNvSpPr>
+            <a:spLocks noGrp="1"/>
+          </p:cNvSpPr>
+          <p:nvPr>
+            <p:ph type="body" idx="3" sz="quarter"/>
+          </p:nvPr>
+        </p:nvSpPr>
+        <p:spPr/>
+        <p:txBody>
+          <a:bodyPr/>
+          <a:lstStyle/>
+          <a:p>
+            <a:r>
+              <a:t>Segurança não é 'custo opcional': uma violação custa milhões e leva ~6 meses só para ser detectada. 60% das brechas exploram vulnerabilidades JÁ conhecidas — ou seja, corrigíveis. A mensagem: tratar segurança cedo é mais barato do que remediar depois.</a:t>
+            </a:r>
+          </a:p>
+        </p:txBody>
+      </p:sp>
+      <p:sp>
+        <p:nvSpPr>
+          <p:cNvPr id="4" name="Slide Number Placeholder 3"/>
+          <p:cNvSpPr>
+            <a:spLocks noGrp="1"/>
+          </p:cNvSpPr>
+          <p:nvPr>
+            <p:ph type="sldNum" idx="5" sz="quarter"/>
+          </p:nvPr>
+        </p:nvSpPr>
+        <p:spPr/>
+      </p:sp>
+    </p:spTree>
+  </p:cSld>
+  <p:clrMapOvr>
+    <a:masterClrMapping/>
+  </p:clrMapOvr>
+</p:notes>
+</file>
+
+<file path=ppt/notesSlides/notesSlide3.xml><?xml version="1.0" encoding="utf-8"?>
+<p:notes xmlns:a="http://schemas.openxmlformats.org/drawingml/2006/main" xmlns:p="http://schemas.openxmlformats.org/presentationml/2006/main" xmlns:r="http://schemas.openxmlformats.org/officeDocument/2006/relationships">
+  <p:cSld>
+    <p:spTree>
+      <p:nvGrpSpPr>
+        <p:cNvPr id="1" name=""/>
+        <p:cNvGrpSpPr/>
+        <p:nvPr/>
+      </p:nvGrpSpPr>
+      <p:grpSpPr>
+        <a:xfrm>
+          <a:off x="0" y="0"/>
+          <a:ext cx="0" cy="0"/>
+          <a:chOff x="0" y="0"/>
+          <a:chExt cx="0" cy="0"/>
+        </a:xfrm>
+      </p:grpSpPr>
+      <p:sp>
+        <p:nvSpPr>
+          <p:cNvPr id="2" name="Slide Image Placeholder 1"/>
+          <p:cNvSpPr>
+            <a:spLocks noGrp="1"/>
+          </p:cNvSpPr>
+          <p:nvPr>
+            <p:ph type="sldImg" idx="2"/>
+          </p:nvPr>
+        </p:nvSpPr>
+        <p:spPr/>
+      </p:sp>
+      <p:sp>
+        <p:nvSpPr>
+          <p:cNvPr id="3" name="Notes Placeholder 2"/>
+          <p:cNvSpPr>
+            <a:spLocks noGrp="1"/>
+          </p:cNvSpPr>
+          <p:nvPr>
+            <p:ph type="body" idx="3" sz="quarter"/>
+          </p:nvPr>
+        </p:nvSpPr>
+        <p:spPr/>
+        <p:txBody>
+          <a:bodyPr/>
+          <a:lstStyle/>
+          <a:p>
+            <a:r>
+              <a:t>O SDLC tradicional trata segurança como um teste no fim (pentest na véspera do release) — quando corrigir é caro e muitas vezes 'adia-se'. O SSDLC (Secure SDLC) embute segurança em requisitos, design, código, teste e operação. Corrigir um bug na fase de requisitos custa até 100x menos que em produção (curva do NIST/IBM).</a:t>
+            </a:r>
+          </a:p>
+        </p:txBody>
+      </p:sp>
+      <p:sp>
+        <p:nvSpPr>
+          <p:cNvPr id="4" name="Slide Number Placeholder 3"/>
+          <p:cNvSpPr>
+            <a:spLocks noGrp="1"/>
+          </p:cNvSpPr>
+          <p:nvPr>
+            <p:ph type="sldNum" idx="5" sz="quarter"/>
+          </p:nvPr>
+        </p:nvSpPr>
+        <p:spPr/>
+      </p:sp>
+    </p:spTree>
+  </p:cSld>
+  <p:clrMapOvr>
+    <a:masterClrMapping/>
+  </p:clrMapOvr>
+</p:notes>
+</file>
+
+<file path=ppt/notesSlides/notesSlide4.xml><?xml version="1.0" encoding="utf-8"?>
+<p:notes xmlns:a="http://schemas.openxmlformats.org/drawingml/2006/main" xmlns:p="http://schemas.openxmlformats.org/presentationml/2006/main" xmlns:r="http://schemas.openxmlformats.org/officeDocument/2006/relationships">
+  <p:cSld>
+    <p:spTree>
+      <p:nvGrpSpPr>
+        <p:cNvPr id="1" name=""/>
+        <p:cNvGrpSpPr/>
+        <p:nvPr/>
+      </p:nvGrpSpPr>
+      <p:grpSpPr>
+        <a:xfrm>
+          <a:off x="0" y="0"/>
+          <a:ext cx="0" cy="0"/>
+          <a:chOff x="0" y="0"/>
+          <a:chExt cx="0" cy="0"/>
+        </a:xfrm>
+      </p:grpSpPr>
+      <p:sp>
+        <p:nvSpPr>
+          <p:cNvPr id="2" name="Slide Image Placeholder 1"/>
+          <p:cNvSpPr>
+            <a:spLocks noGrp="1"/>
+          </p:cNvSpPr>
+          <p:nvPr>
+            <p:ph type="sldImg" idx="2"/>
+          </p:nvPr>
+        </p:nvSpPr>
+        <p:spPr/>
+      </p:sp>
+      <p:sp>
+        <p:nvSpPr>
+          <p:cNvPr id="3" name="Notes Placeholder 2"/>
+          <p:cNvSpPr>
+            <a:spLocks noGrp="1"/>
+          </p:cNvSpPr>
+          <p:nvPr>
+            <p:ph type="body" idx="3" sz="quarter"/>
+          </p:nvPr>
+        </p:nvSpPr>
+        <p:spPr/>
+        <p:txBody>
+          <a:bodyPr/>
+          <a:lstStyle/>
+          <a:p>
+            <a:r>
+              <a:t>A tríade clássica é CIA (Confidentiality, Integrity, Availability). Sistemas modernos acrescentam Autenticidade, Autorização e Não-repúdio. Toda ameaça viola um desses atributos e todo requisito de segurança existe para preservar um deles — por isso o 1º passo de qualquer requisito é perguntar 'qual atributo preciso garantir aqui?'.</a:t>
+            </a:r>
+          </a:p>
+        </p:txBody>
+      </p:sp>
+      <p:sp>
+        <p:nvSpPr>
+          <p:cNvPr id="4" name="Slide Number Placeholder 3"/>
+          <p:cNvSpPr>
+            <a:spLocks noGrp="1"/>
+          </p:cNvSpPr>
+          <p:nvPr>
+            <p:ph type="sldNum" idx="5" sz="quarter"/>
+          </p:nvPr>
+        </p:nvSpPr>
+        <p:spPr/>
+      </p:sp>
+    </p:spTree>
+  </p:cSld>
+  <p:clrMapOvr>
+    <a:masterClrMapping/>
+  </p:clrMapOvr>
+</p:notes>
+</file>
+
+<file path=ppt/notesSlides/notesSlide5.xml><?xml version="1.0" encoding="utf-8"?>
+<p:notes xmlns:a="http://schemas.openxmlformats.org/drawingml/2006/main" xmlns:p="http://schemas.openxmlformats.org/presentationml/2006/main" xmlns:r="http://schemas.openxmlformats.org/officeDocument/2006/relationships">
+  <p:cSld>
+    <p:spTree>
+      <p:nvGrpSpPr>
+        <p:cNvPr id="1" name=""/>
+        <p:cNvGrpSpPr/>
+        <p:nvPr/>
+      </p:nvGrpSpPr>
+      <p:grpSpPr>
+        <a:xfrm>
+          <a:off x="0" y="0"/>
+          <a:ext cx="0" cy="0"/>
+          <a:chOff x="0" y="0"/>
+          <a:chExt cx="0" cy="0"/>
+        </a:xfrm>
+      </p:grpSpPr>
+      <p:sp>
+        <p:nvSpPr>
+          <p:cNvPr id="2" name="Slide Image Placeholder 1"/>
+          <p:cNvSpPr>
+            <a:spLocks noGrp="1"/>
+          </p:cNvSpPr>
+          <p:nvPr>
+            <p:ph type="sldImg" idx="2"/>
+          </p:nvPr>
+        </p:nvSpPr>
+        <p:spPr/>
+      </p:sp>
+      <p:sp>
+        <p:nvSpPr>
+          <p:cNvPr id="3" name="Notes Placeholder 2"/>
+          <p:cNvSpPr>
+            <a:spLocks noGrp="1"/>
+          </p:cNvSpPr>
+          <p:nvPr>
+            <p:ph type="body" idx="3" sz="quarter"/>
+          </p:nvPr>
+        </p:nvSpPr>
+        <p:spPr/>
+        <p:txBody>
+          <a:bodyPr/>
+          <a:lstStyle/>
+          <a:p>
+            <a:r>
+              <a:t>Classificar é um exercício de SEGURANÇA (por impacto), não de direito: pergunte 'que dano se este dado vazar/for alterado?'. Quanto maior o dano, maior o nível, e o nível calibra o rigor (e o custo) dos controles. No VidaPlus, laudo de exame é dado de saúde = o mais sensível = Crítico. A base legal (LGPD) que fundamenta isso vem na Aula 2.</a:t>
+            </a:r>
+          </a:p>
+        </p:txBody>
+      </p:sp>
+      <p:sp>
+        <p:nvSpPr>
+          <p:cNvPr id="4" name="Slide Number Placeholder 3"/>
+          <p:cNvSpPr>
+            <a:spLocks noGrp="1"/>
+          </p:cNvSpPr>
+          <p:nvPr>
+            <p:ph type="sldNum" idx="5" sz="quarter"/>
+          </p:nvPr>
+        </p:nvSpPr>
+        <p:spPr/>
+      </p:sp>
+    </p:spTree>
+  </p:cSld>
+  <p:clrMapOvr>
+    <a:masterClrMapping/>
+  </p:clrMapOvr>
+</p:notes>
+</file>
+
+<file path=ppt/notesSlides/notesSlide6.xml><?xml version="1.0" encoding="utf-8"?>
+<p:notes xmlns:a="http://schemas.openxmlformats.org/drawingml/2006/main" xmlns:p="http://schemas.openxmlformats.org/presentationml/2006/main" xmlns:r="http://schemas.openxmlformats.org/officeDocument/2006/relationships">
+  <p:cSld>
+    <p:spTree>
+      <p:nvGrpSpPr>
+        <p:cNvPr id="1" name=""/>
+        <p:cNvGrpSpPr/>
+        <p:nvPr/>
+      </p:nvGrpSpPr>
+      <p:grpSpPr>
+        <a:xfrm>
+          <a:off x="0" y="0"/>
+          <a:ext cx="0" cy="0"/>
+          <a:chOff x="0" y="0"/>
+          <a:chExt cx="0" cy="0"/>
+        </a:xfrm>
+      </p:grpSpPr>
+      <p:sp>
+        <p:nvSpPr>
+          <p:cNvPr id="2" name="Slide Image Placeholder 1"/>
+          <p:cNvSpPr>
+            <a:spLocks noGrp="1"/>
+          </p:cNvSpPr>
+          <p:nvPr>
+            <p:ph type="sldImg" idx="2"/>
+          </p:nvPr>
+        </p:nvSpPr>
+        <p:spPr/>
+      </p:sp>
+      <p:sp>
+        <p:nvSpPr>
+          <p:cNvPr id="3" name="Notes Placeholder 2"/>
+          <p:cNvSpPr>
+            <a:spLocks noGrp="1"/>
+          </p:cNvSpPr>
+          <p:nvPr>
+            <p:ph type="body" idx="3" sz="quarter"/>
+          </p:nvPr>
+        </p:nvSpPr>
+        <p:spPr/>
+        <p:txBody>
+          <a:bodyPr/>
+          <a:lstStyle/>
+          <a:p>
+            <a:r>
+              <a:t>Um fluxo herda o nível do dado MAIS sensível que ele toca. Exemplo: a busca de pacientes é 'só um formulário', mas retorna CPF e vínculo com exames — logo é crítica. Isso evita o erro de proteger a tela de login com rigor e deixar a busca desprotegida.</a:t>
+            </a:r>
+          </a:p>
+        </p:txBody>
+      </p:sp>
+      <p:sp>
+        <p:nvSpPr>
+          <p:cNvPr id="4" name="Slide Number Placeholder 3"/>
+          <p:cNvSpPr>
+            <a:spLocks noGrp="1"/>
+          </p:cNvSpPr>
+          <p:nvPr>
+            <p:ph type="sldNum" idx="5" sz="quarter"/>
+          </p:nvPr>
+        </p:nvSpPr>
+        <p:spPr/>
+      </p:sp>
+    </p:spTree>
+  </p:cSld>
+  <p:clrMapOvr>
+    <a:masterClrMapping/>
+  </p:clrMapOvr>
+</p:notes>
+</file>
+
+<file path=ppt/notesSlides/notesSlide7.xml><?xml version="1.0" encoding="utf-8"?>
+<p:notes xmlns:a="http://schemas.openxmlformats.org/drawingml/2006/main" xmlns:p="http://schemas.openxmlformats.org/presentationml/2006/main" xmlns:r="http://schemas.openxmlformats.org/officeDocument/2006/relationships">
+  <p:cSld>
+    <p:spTree>
+      <p:nvGrpSpPr>
+        <p:cNvPr id="1" name=""/>
+        <p:cNvGrpSpPr/>
+        <p:nvPr/>
+      </p:nvGrpSpPr>
+      <p:grpSpPr>
+        <a:xfrm>
+          <a:off x="0" y="0"/>
+          <a:ext cx="0" cy="0"/>
+          <a:chOff x="0" y="0"/>
+          <a:chExt cx="0" cy="0"/>
+        </a:xfrm>
+      </p:grpSpPr>
+      <p:sp>
+        <p:nvSpPr>
+          <p:cNvPr id="2" name="Slide Image Placeholder 1"/>
+          <p:cNvSpPr>
+            <a:spLocks noGrp="1"/>
+          </p:cNvSpPr>
+          <p:nvPr>
+            <p:ph type="sldImg" idx="2"/>
+          </p:nvPr>
+        </p:nvSpPr>
+        <p:spPr/>
+      </p:sp>
+      <p:sp>
+        <p:nvSpPr>
+          <p:cNvPr id="3" name="Notes Placeholder 2"/>
+          <p:cNvSpPr>
+            <a:spLocks noGrp="1"/>
+          </p:cNvSpPr>
+          <p:nvPr>
+            <p:ph type="body" idx="3" sz="quarter"/>
+          </p:nvPr>
+        </p:nvSpPr>
+        <p:spPr/>
+        <p:txBody>
+          <a:bodyPr/>
+          <a:lstStyle/>
+          <a:p>
+            <a:r>
+              <a:t>Entregável concreto: uma tabela de inventário + classificação. NÃO se exige LGPD ainda — só a intuição de sensibilidade. A coluna 'base legal' será preenchida na Fase 1, após a aula de LGPD. Suba o VidaPlus com 'docker compose up' e explore as telas para levantar os ativos.</a:t>
+            </a:r>
+          </a:p>
+        </p:txBody>
+      </p:sp>
+      <p:sp>
+        <p:nvSpPr>
+          <p:cNvPr id="4" name="Slide Number Placeholder 3"/>
+          <p:cNvSpPr>
+            <a:spLocks noGrp="1"/>
+          </p:cNvSpPr>
+          <p:nvPr>
+            <p:ph type="sldNum" idx="5" sz="quarter"/>
+          </p:nvPr>
+        </p:nvSpPr>
+        <p:spPr/>
+      </p:sp>
+    </p:spTree>
+  </p:cSld>
+  <p:clrMapOvr>
+    <a:masterClrMapping/>
+  </p:clrMapOvr>
+</p:notes>
 </file>
 
 <file path=ppt/slideLayouts/slideLayout1.xml><?xml version="1.0" encoding="utf-8"?>
@@ -3688,7 +4528,7 @@
                 </a:solidFill>
                 <a:latin typeface="Open Sans"/>
               </a:rPr>
-              <a:t>ativos, telas, endpoints e tabelas do VidaPlus.</a:t>
+              <a:t>liste ativos, telas, endpoints e tabelas do VidaPlus.</a:t>
             </a:r>
           </a:p>
           <a:p>
@@ -3725,7 +4565,7 @@
                 </a:solidFill>
                 <a:latin typeface="Open Sans"/>
               </a:rPr>
-              <a:t>por sensibilidade/impacto (Público -&gt; Crítico).</a:t>
+              <a:t>dê a cada dado um nível por sensibilidade/impacto (Público-&gt;Crítico).</a:t>
             </a:r>
           </a:p>
           <a:p>
@@ -3762,7 +4602,7 @@
                 </a:solidFill>
                 <a:latin typeface="Open Sans"/>
               </a:rPr>
-              <a:t>o nível mais alto que um fluxo toca o define.</a:t>
+              <a:t>o nível mais alto que um fluxo toca define o fluxo.</a:t>
             </a:r>
           </a:p>
           <a:p>
@@ -3799,7 +4639,7 @@
                 </a:solidFill>
                 <a:latin typeface="Open Sans"/>
               </a:rPr>
-              <a:t>login, laudo, auditoria.</a:t>
+              <a:t>identifique os 3 principais — login, laudo, auditoria.</a:t>
             </a:r>
           </a:p>
           <a:p>
@@ -3836,7 +4676,7 @@
                 </a:solidFill>
                 <a:latin typeface="Open Sans"/>
               </a:rPr>
-              <a:t>onde o dado cruza zonas de confiança.</a:t>
+              <a:t>marque onde o dado cruza zonas de confiança.</a:t>
             </a:r>
           </a:p>
           <a:p>
@@ -5901,7 +6741,7 @@
                 </a:solidFill>
                 <a:latin typeface="Open Sans"/>
               </a:rPr>
-              <a:t>Compliance reativo.</a:t>
+              <a:t>Compliance reativo (auditoria).</a:t>
             </a:r>
           </a:p>
         </p:txBody>
@@ -6115,7 +6955,7 @@
                 </a:solidFill>
                 <a:latin typeface="Open Sans"/>
               </a:rPr>
-              <a:t>Segurança transversal a tudo.</a:t>
+              <a:t>Segurança transversal a todas as fases.</a:t>
             </a:r>
           </a:p>
           <a:p>
@@ -6171,7 +7011,7 @@
                 </a:solidFill>
                 <a:latin typeface="Open Sans"/>
               </a:rPr>
-              <a:t>Compliance by design.</a:t>
+              <a:t>Compliance 'by design'.</a:t>
             </a:r>
           </a:p>
         </p:txBody>
@@ -6323,7 +7163,7 @@
                 </a:solidFill>
                 <a:latin typeface="Open Sans"/>
               </a:rPr>
-              <a:t>Pilares da segurança</a:t>
+              <a:t>Pilares da segurança da informação</a:t>
             </a:r>
           </a:p>
         </p:txBody>
@@ -6368,7 +7208,7 @@
                 </a:solidFill>
                 <a:latin typeface="Open Sans"/>
               </a:rPr>
-              <a:t>CIA + atributos estendidos (base de todo requisito)</a:t>
+              <a:t>Todo requisito existe para preservar um destes</a:t>
             </a:r>
           </a:p>
         </p:txBody>
@@ -6593,7 +7433,7 @@
                 </a:solidFill>
                 <a:latin typeface="Open Sans"/>
               </a:rPr>
-              <a:t>só autorizados acessam</a:t>
+              <a:t>só quem tem autorização acessa o dado</a:t>
             </a:r>
           </a:p>
         </p:txBody>
@@ -6818,7 +7658,7 @@
                 </a:solidFill>
                 <a:latin typeface="Open Sans"/>
               </a:rPr>
-              <a:t>dados não alterados</a:t>
+              <a:t>o dado não é alterado indevidamente</a:t>
             </a:r>
           </a:p>
         </p:txBody>
@@ -7043,7 +7883,7 @@
                 </a:solidFill>
                 <a:latin typeface="Open Sans"/>
               </a:rPr>
-              <a:t>disponível quando preciso</a:t>
+              <a:t>o sistema está disponível quando preciso</a:t>
             </a:r>
           </a:p>
         </p:txBody>
@@ -7268,7 +8108,7 @@
                 </a:solidFill>
                 <a:latin typeface="Open Sans"/>
               </a:rPr>
-              <a:t>provar quem é quem</a:t>
+              <a:t>provar quem é quem (identidade verificável)</a:t>
             </a:r>
           </a:p>
         </p:txBody>
@@ -7493,7 +8333,7 @@
                 </a:solidFill>
                 <a:latin typeface="Open Sans"/>
               </a:rPr>
-              <a:t>o que pode fazer</a:t>
+              <a:t>após autenticar, o que cada um pode fazer</a:t>
             </a:r>
           </a:p>
         </p:txBody>
@@ -7718,7 +8558,7 @@
                 </a:solidFill>
                 <a:latin typeface="Open Sans"/>
               </a:rPr>
-              <a:t>não negar autoria</a:t>
+              <a:t>não poder negar a autoria de uma ação</a:t>
             </a:r>
           </a:p>
         </p:txBody>
@@ -8156,7 +8996,7 @@
                 </a:solidFill>
                 <a:latin typeface="Open Sans"/>
               </a:rPr>
-              <a:t>Nível -&gt; requisitos típicos</a:t>
+              <a:t>Nível de sensibilidade -&gt; requisitos típicos</a:t>
             </a:r>
           </a:p>
         </p:txBody>
@@ -8336,7 +9176,7 @@
                 </a:solidFill>
                 <a:latin typeface="Open Sans"/>
               </a:rPr>
-              <a:t>PII sensível, saúde, cartão</a:t>
+              <a:t>Saúde, biometria, cartão, PII sensível</a:t>
             </a:r>
           </a:p>
         </p:txBody>
@@ -8561,7 +9401,7 @@
                 </a:solidFill>
                 <a:latin typeface="Open Sans"/>
               </a:rPr>
-              <a:t>Financeiro, segredo comercial</a:t>
+              <a:t>Financeiro pessoal, segredo comercial</a:t>
             </a:r>
           </a:p>
         </p:txBody>
@@ -8831,7 +9671,7 @@
                 </a:solidFill>
                 <a:latin typeface="Open Sans"/>
               </a:rPr>
-              <a:t>Acesso por colaboradores autenticados</a:t>
+              <a:t>Acesso só por colaboradores autenticados</a:t>
             </a:r>
           </a:p>
         </p:txBody>
@@ -9011,7 +9851,7 @@
                 </a:solidFill>
                 <a:latin typeface="Open Sans"/>
               </a:rPr>
-              <a:t>Site, marketing</a:t>
+              <a:t>Site, marketing, blog</a:t>
             </a:r>
           </a:p>
         </p:txBody>
@@ -9343,7 +10183,7 @@
                 </a:solidFill>
                 <a:latin typeface="Open Sans"/>
               </a:rPr>
-              <a:t>O nível mais alto que um fluxo toca define seus requisitos — dado público + CPF passa a ser tratado como crítico.</a:t>
+              <a:t>O nível mais alto que um fluxo toca define os requisitos de todo o fluxo — um formulário público que também recebe CPF passa a ser tratado como crítico.</a:t>
             </a:r>
           </a:p>
         </p:txBody>
@@ -10049,4 +10889,324 @@
   </a:objectDefaults>
   <a:extraClrSchemeLst/>
 </a:theme>
+</file>
+
+<file path=ppt/theme/theme2.xml><?xml version="1.0" encoding="utf-8"?>
+<a:theme xmlns:a="http://schemas.openxmlformats.org/drawingml/2006/main" name="Office Theme">
+  <a:themeElements>
+    <a:clrScheme name="Office">
+      <a:dk1>
+        <a:sysClr val="windowText" lastClr="000000"/>
+      </a:dk1>
+      <a:lt1>
+        <a:sysClr val="window" lastClr="FFFFFF"/>
+      </a:lt1>
+      <a:dk2>
+        <a:srgbClr val="1F497D"/>
+      </a:dk2>
+      <a:lt2>
+        <a:srgbClr val="EEECE1"/>
+      </a:lt2>
+      <a:accent1>
+        <a:srgbClr val="4F81BD"/>
+      </a:accent1>
+      <a:accent2>
+        <a:srgbClr val="C0504D"/>
+      </a:accent2>
+      <a:accent3>
+        <a:srgbClr val="9BBB59"/>
+      </a:accent3>
+      <a:accent4>
+        <a:srgbClr val="8064A2"/>
+      </a:accent4>
+      <a:accent5>
+        <a:srgbClr val="4BACC6"/>
+      </a:accent5>
+      <a:accent6>
+        <a:srgbClr val="F79646"/>
+      </a:accent6>
+      <a:hlink>
+        <a:srgbClr val="0000FF"/>
+      </a:hlink>
+      <a:folHlink>
+        <a:srgbClr val="800080"/>
+      </a:folHlink>
+    </a:clrScheme>
+    <a:fontScheme name="Office">
+      <a:majorFont>
+        <a:latin typeface="Calibri"/>
+        <a:ea typeface=""/>
+        <a:cs typeface=""/>
+        <a:font script="Jpan" typeface="ＭＳ Ｐゴシック"/>
+        <a:font script="Hang" typeface="맑은 고딕"/>
+        <a:font script="Hans" typeface="宋体"/>
+        <a:font script="Hant" typeface="新細明體"/>
+        <a:font script="Arab" typeface="Times New Roman"/>
+        <a:font script="Hebr" typeface="Times New Roman"/>
+        <a:font script="Thai" typeface="Angsana New"/>
+        <a:font script="Ethi" typeface="Nyala"/>
+        <a:font script="Beng" typeface="Vrinda"/>
+        <a:font script="Gujr" typeface="Shruti"/>
+        <a:font script="Khmr" typeface="MoolBoran"/>
+        <a:font script="Knda" typeface="Tunga"/>
+        <a:font script="Guru" typeface="Raavi"/>
+        <a:font script="Cans" typeface="Euphemia"/>
+        <a:font script="Cher" typeface="Plantagenet Cherokee"/>
+        <a:font script="Yiii" typeface="Microsoft Yi Baiti"/>
+        <a:font script="Tibt" typeface="Microsoft Himalaya"/>
+        <a:font script="Thaa" typeface="MV Boli"/>
+        <a:font script="Deva" typeface="Mangal"/>
+        <a:font script="Telu" typeface="Gautami"/>
+        <a:font script="Taml" typeface="Latha"/>
+        <a:font script="Syrc" typeface="Estrangelo Edessa"/>
+        <a:font script="Orya" typeface="Kalinga"/>
+        <a:font script="Mlym" typeface="Kartika"/>
+        <a:font script="Laoo" typeface="DokChampa"/>
+        <a:font script="Sinh" typeface="Iskoola Pota"/>
+        <a:font script="Mong" typeface="Mongolian Baiti"/>
+        <a:font script="Viet" typeface="Times New Roman"/>
+        <a:font script="Uigh" typeface="Microsoft Uighur"/>
+        <a:font script="Geor" typeface="Sylfaen"/>
+      </a:majorFont>
+      <a:minorFont>
+        <a:latin typeface="Calibri"/>
+        <a:ea typeface=""/>
+        <a:cs typeface=""/>
+        <a:font script="Jpan" typeface="ＭＳ Ｐゴシック"/>
+        <a:font script="Hang" typeface="맑은 고딕"/>
+        <a:font script="Hans" typeface="宋体"/>
+        <a:font script="Hant" typeface="新細明體"/>
+        <a:font script="Arab" typeface="Arial"/>
+        <a:font script="Hebr" typeface="Arial"/>
+        <a:font script="Thai" typeface="Cordia New"/>
+        <a:font script="Ethi" typeface="Nyala"/>
+        <a:font script="Beng" typeface="Vrinda"/>
+        <a:font script="Gujr" typeface="Shruti"/>
+        <a:font script="Khmr" typeface="DaunPenh"/>
+        <a:font script="Knda" typeface="Tunga"/>
+        <a:font script="Guru" typeface="Raavi"/>
+        <a:font script="Cans" typeface="Euphemia"/>
+        <a:font script="Cher" typeface="Plantagenet Cherokee"/>
+        <a:font script="Yiii" typeface="Microsoft Yi Baiti"/>
+        <a:font script="Tibt" typeface="Microsoft Himalaya"/>
+        <a:font script="Thaa" typeface="MV Boli"/>
+        <a:font script="Deva" typeface="Mangal"/>
+        <a:font script="Telu" typeface="Gautami"/>
+        <a:font script="Taml" typeface="Latha"/>
+        <a:font script="Syrc" typeface="Estrangelo Edessa"/>
+        <a:font script="Orya" typeface="Kalinga"/>
+        <a:font script="Mlym" typeface="Kartika"/>
+        <a:font script="Laoo" typeface="DokChampa"/>
+        <a:font script="Sinh" typeface="Iskoola Pota"/>
+        <a:font script="Mong" typeface="Mongolian Baiti"/>
+        <a:font script="Viet" typeface="Arial"/>
+        <a:font script="Uigh" typeface="Microsoft Uighur"/>
+        <a:font script="Geor" typeface="Sylfaen"/>
+      </a:minorFont>
+    </a:fontScheme>
+    <a:fmtScheme name="Office">
+      <a:fillStyleLst>
+        <a:solidFill>
+          <a:schemeClr val="phClr"/>
+        </a:solidFill>
+        <a:gradFill rotWithShape="1">
+          <a:gsLst>
+            <a:gs pos="0">
+              <a:schemeClr val="phClr">
+                <a:tint val="50000"/>
+                <a:satMod val="300000"/>
+              </a:schemeClr>
+            </a:gs>
+            <a:gs pos="35000">
+              <a:schemeClr val="phClr">
+                <a:tint val="37000"/>
+                <a:satMod val="300000"/>
+              </a:schemeClr>
+            </a:gs>
+            <a:gs pos="100000">
+              <a:schemeClr val="phClr">
+                <a:tint val="15000"/>
+                <a:satMod val="350000"/>
+              </a:schemeClr>
+            </a:gs>
+          </a:gsLst>
+          <a:lin ang="16200000" scaled="1"/>
+        </a:gradFill>
+        <a:gradFill rotWithShape="1">
+          <a:gsLst>
+            <a:gs pos="0">
+              <a:schemeClr val="phClr">
+                <a:tint val="100000"/>
+                <a:shade val="100000"/>
+                <a:satMod val="130000"/>
+              </a:schemeClr>
+            </a:gs>
+            <a:gs pos="100000">
+              <a:schemeClr val="phClr">
+                <a:tint val="50000"/>
+                <a:shade val="100000"/>
+                <a:satMod val="350000"/>
+              </a:schemeClr>
+            </a:gs>
+          </a:gsLst>
+          <a:lin ang="16200000" scaled="0"/>
+        </a:gradFill>
+      </a:fillStyleLst>
+      <a:lnStyleLst>
+        <a:ln w="9525" cap="flat" cmpd="sng" algn="ctr">
+          <a:solidFill>
+            <a:schemeClr val="phClr">
+              <a:shade val="95000"/>
+              <a:satMod val="105000"/>
+            </a:schemeClr>
+          </a:solidFill>
+          <a:prstDash val="solid"/>
+        </a:ln>
+        <a:ln w="25400" cap="flat" cmpd="sng" algn="ctr">
+          <a:solidFill>
+            <a:schemeClr val="phClr"/>
+          </a:solidFill>
+          <a:prstDash val="solid"/>
+        </a:ln>
+        <a:ln w="38100" cap="flat" cmpd="sng" algn="ctr">
+          <a:solidFill>
+            <a:schemeClr val="phClr"/>
+          </a:solidFill>
+          <a:prstDash val="solid"/>
+        </a:ln>
+      </a:lnStyleLst>
+      <a:effectStyleLst>
+        <a:effectStyle>
+          <a:effectLst>
+            <a:outerShdw blurRad="40000" dist="20000" dir="5400000" rotWithShape="0">
+              <a:srgbClr val="000000">
+                <a:alpha val="38000"/>
+              </a:srgbClr>
+            </a:outerShdw>
+          </a:effectLst>
+        </a:effectStyle>
+        <a:effectStyle>
+          <a:effectLst>
+            <a:outerShdw blurRad="40000" dist="23000" dir="5400000" rotWithShape="0">
+              <a:srgbClr val="000000">
+                <a:alpha val="35000"/>
+              </a:srgbClr>
+            </a:outerShdw>
+          </a:effectLst>
+        </a:effectStyle>
+        <a:effectStyle>
+          <a:effectLst>
+            <a:outerShdw blurRad="40000" dist="23000" dir="5400000" rotWithShape="0">
+              <a:srgbClr val="000000">
+                <a:alpha val="35000"/>
+              </a:srgbClr>
+            </a:outerShdw>
+          </a:effectLst>
+          <a:scene3d>
+            <a:camera prst="orthographicFront">
+              <a:rot lat="0" lon="0" rev="0"/>
+            </a:camera>
+            <a:lightRig rig="threePt" dir="t">
+              <a:rot lat="0" lon="0" rev="1200000"/>
+            </a:lightRig>
+          </a:scene3d>
+          <a:sp3d>
+            <a:bevelT w="63500" h="25400"/>
+          </a:sp3d>
+        </a:effectStyle>
+      </a:effectStyleLst>
+      <a:bgFillStyleLst>
+        <a:solidFill>
+          <a:schemeClr val="phClr"/>
+        </a:solidFill>
+        <a:gradFill rotWithShape="1">
+          <a:gsLst>
+            <a:gs pos="0">
+              <a:schemeClr val="phClr">
+                <a:tint val="40000"/>
+                <a:satMod val="350000"/>
+              </a:schemeClr>
+            </a:gs>
+            <a:gs pos="40000">
+              <a:schemeClr val="phClr">
+                <a:tint val="45000"/>
+                <a:shade val="99000"/>
+                <a:satMod val="350000"/>
+              </a:schemeClr>
+            </a:gs>
+            <a:gs pos="100000">
+              <a:schemeClr val="phClr">
+                <a:shade val="20000"/>
+                <a:satMod val="255000"/>
+              </a:schemeClr>
+            </a:gs>
+          </a:gsLst>
+          <a:path path="circle">
+            <a:fillToRect l="50000" t="-80000" r="50000" b="180000"/>
+          </a:path>
+        </a:gradFill>
+        <a:gradFill rotWithShape="1">
+          <a:gsLst>
+            <a:gs pos="0">
+              <a:schemeClr val="phClr">
+                <a:tint val="80000"/>
+                <a:satMod val="300000"/>
+              </a:schemeClr>
+            </a:gs>
+            <a:gs pos="100000">
+              <a:schemeClr val="phClr">
+                <a:shade val="30000"/>
+                <a:satMod val="200000"/>
+              </a:schemeClr>
+            </a:gs>
+          </a:gsLst>
+          <a:path path="circle">
+            <a:fillToRect l="50000" t="50000" r="50000" b="50000"/>
+          </a:path>
+        </a:gradFill>
+      </a:bgFillStyleLst>
+    </a:fmtScheme>
+  </a:themeElements>
+  <a:objectDefaults>
+    <a:spDef>
+      <a:spPr/>
+      <a:bodyPr/>
+      <a:lstStyle/>
+      <a:style>
+        <a:lnRef idx="1">
+          <a:schemeClr val="accent1"/>
+        </a:lnRef>
+        <a:fillRef idx="3">
+          <a:schemeClr val="accent1"/>
+        </a:fillRef>
+        <a:effectRef idx="2">
+          <a:schemeClr val="accent1"/>
+        </a:effectRef>
+        <a:fontRef idx="minor">
+          <a:schemeClr val="lt1"/>
+        </a:fontRef>
+      </a:style>
+    </a:spDef>
+    <a:lnDef>
+      <a:spPr/>
+      <a:bodyPr/>
+      <a:lstStyle/>
+      <a:style>
+        <a:lnRef idx="2">
+          <a:schemeClr val="accent1"/>
+        </a:lnRef>
+        <a:fillRef idx="0">
+          <a:schemeClr val="accent1"/>
+        </a:fillRef>
+        <a:effectRef idx="1">
+          <a:schemeClr val="accent1"/>
+        </a:effectRef>
+        <a:fontRef idx="minor">
+          <a:schemeClr val="tx1"/>
+        </a:fontRef>
+      </a:style>
+    </a:lnDef>
+  </a:objectDefaults>
+  <a:extraClrSchemeLst/>
+</a:theme>
 </file>
</xml_diff>

<commit_message>
Aulas mais claras: entregaveis objetivos + exemplos trabalhados + glossario
- Entregaveis (10 aulas): padrao unico - artefato + secao do dossie + "Pronto quando"
  (criterio de conclusao); cada fase aponta a subsecao de docs/10
- Aula 5: priorizacao reescrita (gravidade CVSS/DREAD x exploracao EPSS/KEV -> P0/P1/P2),
  sem o mapeamento 1:1 ambiguo; rubrica (docs/08) alinhada
- Aula 6: OWASP Top 10:2025 completo (10 categorias em 2 slides) com mapa p/ VidaPlus
- Aula 9: runbook-exemplo (vazamento de laudo) + apostila; docs/10 §9 com prompts por passo
- Glossario (docs/11): hash-chain (expandido), Linter, Proveniencia/SLSA/Sigstore
- Apostila (docs/12): runbook detalhado

Co-Authored-By: Claude Opus 4.8 <noreply@anthropic.com>
</commit_message>
<xml_diff>
--- a/aulas/aula-01-contexto-e-dados.pptx
+++ b/aulas/aula-01-contexto-e-dados.pptx
@@ -9017,7 +9017,7 @@
                 </a:solidFill>
                 <a:latin typeface="Open Sans"/>
               </a:rPr>
-              <a:t>O que o grupo produz esta semana</a:t>
+              <a:t>Uma tabela de inventário + classificação (dossiê §1)</a:t>
             </a:r>
           </a:p>
         </p:txBody>
@@ -9114,7 +9114,7 @@
                 </a:solidFill>
                 <a:latin typeface="Open Sans"/>
               </a:rPr>
-              <a:t>Inventário: </a:t>
+              <a:t>Entregar: </a:t>
             </a:r>
             <a:r>
               <a:rPr sz="1800">
@@ -9123,7 +9123,7 @@
                 </a:solidFill>
                 <a:latin typeface="Open Sans"/>
               </a:rPr>
-              <a:t>liste ativos, telas, endpoints e tabelas do VidaPlus.</a:t>
+              <a:t>tabela com ativo / tela / endpoint / tabela + nível de sensibilidade (Público-&gt;Crítico).</a:t>
             </a:r>
           </a:p>
           <a:p>
@@ -9151,7 +9151,7 @@
                 </a:solidFill>
                 <a:latin typeface="Open Sans"/>
               </a:rPr>
-              <a:t>Classificação: </a:t>
+              <a:t>Fluxos críticos: </a:t>
             </a:r>
             <a:r>
               <a:rPr sz="1800">
@@ -9160,7 +9160,7 @@
                 </a:solidFill>
                 <a:latin typeface="Open Sans"/>
               </a:rPr>
-              <a:t>dê a cada dado um nível por sensibilidade/impacto (Público-&gt;Crítico).</a:t>
+              <a:t>os 3 principais (login, laudo, auditoria) com suas trust boundaries.</a:t>
             </a:r>
           </a:p>
           <a:p>
@@ -9197,7 +9197,7 @@
                 </a:solidFill>
                 <a:latin typeface="Open Sans"/>
               </a:rPr>
-              <a:t>o nível mais alto que um fluxo toca define o fluxo.</a:t>
+              <a:t>o fluxo herda o nível do dado mais sensível que ele toca.</a:t>
             </a:r>
           </a:p>
           <a:p>
@@ -9225,7 +9225,7 @@
                 </a:solidFill>
                 <a:latin typeface="Open Sans"/>
               </a:rPr>
-              <a:t>Fluxos críticos: </a:t>
+              <a:t>Ainda NÃO: </a:t>
             </a:r>
             <a:r>
               <a:rPr sz="1800">
@@ -9234,7 +9234,7 @@
                 </a:solidFill>
                 <a:latin typeface="Open Sans"/>
               </a:rPr>
-              <a:t>identifique os 3 principais — login, laudo, auditoria.</a:t>
+              <a:t>base legal LGPD (vem na Fase 1) — aqui só marque o que é sensível.</a:t>
             </a:r>
           </a:p>
           <a:p>
@@ -9262,7 +9262,7 @@
                 </a:solidFill>
                 <a:latin typeface="Open Sans"/>
               </a:rPr>
-              <a:t>Trust boundaries: </a:t>
+              <a:t>Pronto quando: </a:t>
             </a:r>
             <a:r>
               <a:rPr sz="1800">
@@ -9271,44 +9271,7 @@
                 </a:solidFill>
                 <a:latin typeface="Open Sans"/>
               </a:rPr>
-              <a:t>marque onde o dado cruza zonas de confiança.</a:t>
-            </a:r>
-          </a:p>
-          <a:p>
-            <a:pPr algn="l">
-              <a:lnSpc>
-                <a:spcPct val="110000"/>
-              </a:lnSpc>
-              <a:spcAft>
-                <a:spcPts val="1400"/>
-              </a:spcAft>
-            </a:pPr>
-            <a:r>
-              <a:rPr sz="2000" b="1">
-                <a:solidFill>
-                  <a:srgbClr val="7CB342"/>
-                </a:solidFill>
-                <a:latin typeface="Open Sans"/>
-              </a:rPr>
-              <a:t>▸ </a:t>
-            </a:r>
-            <a:r>
-              <a:rPr sz="1800" b="1">
-                <a:solidFill>
-                  <a:srgbClr val="2D7A3D"/>
-                </a:solidFill>
-                <a:latin typeface="Open Sans"/>
-              </a:rPr>
-              <a:t>Base legal (LGPD): </a:t>
-            </a:r>
-            <a:r>
-              <a:rPr sz="1800">
-                <a:solidFill>
-                  <a:srgbClr val="212121"/>
-                </a:solidFill>
-                <a:latin typeface="Open Sans"/>
-              </a:rPr>
-              <a:t>só na Fase 1 — aqui, apenas marque o que é sensível.</a:t>
+              <a:t>todo dado tem um nível e os 3 fluxos críticos estão mapeados.</a:t>
             </a:r>
           </a:p>
         </p:txBody>

</xml_diff>

<commit_message>
docs(11,aula-01): propaga o deslocamento de semanas (Fase 1 = 2 semanas)
Ripple da reprogramacao (Fase 1 ganhou a semana 3; Fases 2-8 deslocam +1;
defesas na semana 16):
- docs/11 apostila: cronograma-resumo + os 10 cabecalhos "Aula N ·
  Semana N" + a nota de defesas realinhados.
- aula-01 slide 6 (Cronograma do projeto): os 7 cards de fase (Fase 1
  Sem 2-3 ... Fase 8 Sem 15) e o rodape (Semana 16) atualizados no XML
  do pptx. Os demais 8 decks usam "a etapa desta semana (Fase N)"
  (relativo) - nada a mudar. Render conferido.

Co-Authored-By: Claude Opus 4.8 <noreply@anthropic.com>
</commit_message>
<xml_diff>
--- a/aulas/aula-01-contexto-e-dados.pptx
+++ b/aulas/aula-01-contexto-e-dados.pptx
@@ -12357,7 +12357,7 @@
                 </a:solidFill>
                 <a:latin typeface="Open Sans"/>
               </a:rPr>
-              <a:t>Fase 1 · Sem 2</a:t>
+              <a:t>Fase 1 · Sem 2–3</a:t>
             </a:r>
           </a:p>
         </p:txBody>
@@ -12582,7 +12582,7 @@
                 </a:solidFill>
                 <a:latin typeface="Open Sans"/>
               </a:rPr>
-              <a:t>Fase 2 · Sem 3–4</a:t>
+              <a:t>Fase 2 · Sem 4–5</a:t>
             </a:r>
           </a:p>
         </p:txBody>
@@ -12807,7 +12807,7 @@
                 </a:solidFill>
                 <a:latin typeface="Open Sans"/>
               </a:rPr>
-              <a:t>Fase 3 · Sem 5</a:t>
+              <a:t>Fase 3 · Sem 6</a:t>
             </a:r>
           </a:p>
         </p:txBody>
@@ -13032,7 +13032,7 @@
                 </a:solidFill>
                 <a:latin typeface="Open Sans"/>
               </a:rPr>
-              <a:t>Fase 4 · Sem 6–9</a:t>
+              <a:t>Fase 4 · Sem 7–10</a:t>
             </a:r>
           </a:p>
         </p:txBody>
@@ -13257,7 +13257,7 @@
                 </a:solidFill>
                 <a:latin typeface="Open Sans"/>
               </a:rPr>
-              <a:t>Fase 5 · Sem 10–11</a:t>
+              <a:t>Fase 5 · Sem 11–12</a:t>
             </a:r>
           </a:p>
         </p:txBody>
@@ -13482,7 +13482,7 @@
                 </a:solidFill>
                 <a:latin typeface="Open Sans"/>
               </a:rPr>
-              <a:t>Fases 6–7 · Sem 12–13</a:t>
+              <a:t>Fases 6–7 · Sem 13–14</a:t>
             </a:r>
           </a:p>
         </p:txBody>
@@ -13707,7 +13707,7 @@
                 </a:solidFill>
                 <a:latin typeface="Open Sans"/>
               </a:rPr>
-              <a:t>Fase 8 · Sem 14</a:t>
+              <a:t>Fase 8 · Sem 15</a:t>
             </a:r>
           </a:p>
         </p:txBody>
@@ -13841,7 +13841,7 @@
                 </a:solidFill>
                 <a:latin typeface="Open Sans"/>
               </a:rPr>
-              <a:t>Semanas 15–16: defesas — fechar o fio completo ao vivo.</a:t>
+              <a:t>Semana 16: defesas — fechar o fio completo ao vivo.</a:t>
             </a:r>
           </a:p>
         </p:txBody>

</xml_diff>